<commit_message>
Present as a group project, no lead designation; put my name first across all documents
</commit_message>
<xml_diff>
--- a/docs/CS790_G3_Final_Slides.pptx
+++ b/docs/CS790_G3_Final_Slides.pptx
@@ -7578,7 +7578,7 @@
                 <a:cs typeface="Calibri"/>
                 <a:sym typeface="Calibri"/>
               </a:rPr>
-              <a:t>Zulal Akarsu  ·  Jai Sharma  ·  María Martín</a:t>
+              <a:t>María Martín  ·  Zulal Akarsu  ·  Jai Sharma</a:t>
             </a:r>
             <a:endParaRPr b="0" i="0" sz="1900" u="none" cap="none" strike="noStrike">
               <a:solidFill>
@@ -24031,7 +24031,7 @@
                 <a:cs typeface="Calibri"/>
                 <a:sym typeface="Calibri"/>
               </a:rPr>
-              <a:t>Group 3  ·  Zulal Akarsu  ·  Jai Sharma  ·  María Martín</a:t>
+              <a:t>Group 3  ·  María Martín  ·  Zulal Akarsu  ·  Jai Sharma</a:t>
             </a:r>
             <a:endParaRPr b="0" i="0" sz="1000" u="none" cap="none" strike="noStrike">
               <a:solidFill>

</xml_diff>